<commit_message>
Documentation and deliverables polish for publication
- Professional tone pass across README, demo guide, submission checklist,
  deck and report generators; corrected informal phrasing
- Repository evaluation results now carry deterministic-only provenance;
  LLM-dependent tables state explicitly that they are populated by the
  demo-machine run (no reference-harness numbers in deliverables)
- Report and deck degrade gracefully where demo-machine measurements are
  pending; removed a hardcoded fallback figure
- Dynamic query counts in the evaluation report; clarified skipped-section
  wording
</commit_message>
<xml_diff>
--- a/deliverables/FlexiGrid_AI_Defense_Deck.pptx
+++ b/deliverables/FlexiGrid_AI_Defense_Deck.pptx
@@ -580,7 +580,7 @@
           <a:lstStyle/>
           <a:p>
             <a:r>
-              <a:t>60s. The household problem: EV, heat pump, appliances; deadlines, comfort, and the Flemish capacity tariff, where one bad quarter-hour raises the bill for twelve months. Then the hook: we measured what happens when you let the language model schedule directly — the violation number on the right. That number is why this architecture exists.</a:t>
+              <a:t>60s. The household problem: EV, heat pump, appliances; deadlines, comfort, and the Flemish capacity tariff, where one bad quarter-hour raises the bill for twelve months. Then present the measurement: Baseline B lets the language model schedule directly, and its violation rate motivates the entire architecture.</a:t>
             </a:r>
           </a:p>
         </p:txBody>
@@ -790,7 +790,7 @@
           <a:lstStyle/>
           <a:p>
             <a:r>
-              <a:t>60s. Map to the course list. Transformer: local Qwen2.5-3B with schema-constrained decoding and a repair loop. Agent: the model chooses the tools. RAG: hybrid BM25 plus dense with rank fusion, three switchable modes. MCP: real server, real client session. Fine-tuning, diffusion, multimodal: excluded with an argument, not ignored — and the intent ablation shows exactly where a LoRA would slot in if extraction became the bottleneck.</a:t>
+              <a:t>60s. Map to the course list. Transformer: local Qwen2.5-3B with schema-constrained decoding and a repair loop. Agent: the model chooses the tools. RAG: hybrid BM25 plus dense with rank fusion, three switchable modes. MCP: real server, real client session. Fine-tuning, diffusion, multimodal: excluded with an explicit argument — and the intent ablation shows exactly where a LoRA fine-tune would apply if extraction became the bottleneck.</a:t>
             </a:r>
           </a:p>
         </p:txBody>
@@ -930,7 +930,7 @@
           <a:lstStyle/>
           <a:p>
             <a:r>
-              <a:t>150s. Demo order: 1) top-bar chip proves the live backend and names the model. 2) run the morning mission — walk the trace: intent chips with sanitizer notes, five tool calls with milliseconds and the llm/guardrail column, retrieval scores, the model's cited explanation. 3) edit the mission live — move the deadline, add avoid-hours — schedule follows. 4) type the impossible mission — critic rejects it, nothing is displayed. 5) terminal: python -m flexigrid.mcp_host shows the same agent over a real MCP session. Fallback if anything dies: offline mode is clearly labelled and the report PDF is open.</a:t>
+              <a:t>150s. Demo order: 1) top-bar chip proves the live backend and names the model. 2) run the morning mission — walk the trace: intent chips with sanitizer notes, five tool calls with milliseconds and the llm/guardrail column, retrieval scores, the model's cited explanation. 3) edit the mission live — move the deadline, add avoid-hours — the schedule follows. 4) submit an infeasible mission — critic rejects it, nothing is displayed. 5) terminal: python -m flexigrid.mcp_host shows the same agent over a real MCP session. Fallback if anything dies: offline mode is clearly labelled and the report PDF is open.</a:t>
             </a:r>
           </a:p>
         </p:txBody>
@@ -1070,7 +1070,7 @@
           <a:lstStyle/>
           <a:p>
             <a:r>
-              <a:t>45s. Proven: free text drives a validated plan through a real agent on real MCP tools with a local model, and the evaluation quantifies why the critic must exist. Next: LoRA for intent once it is the measured bottleneck, MILP at scale, a broader mission set with confidence intervals, carbon-aware objective from ods201. Close by inviting questions on any layer — both of us can walk every file.</a:t>
+              <a:t>45s. Proven: free text drives a validated plan through a real agent on real MCP tools with a local model, and the evaluation quantifies why the critic must exist. Next: LoRA for intent once it is the measured bottleneck, MILP at scale, a broader mission set with confidence intervals, carbon-aware objective from ods201. Close by inviting questions on any layer — both team members can explain every component.</a:t>
             </a:r>
           </a:p>
         </p:txBody>
@@ -4774,7 +4774,7 @@
                   <a:srgbClr val="6C7C76"/>
                 </a:solidFill>
               </a:rPr>
-              <a:t> — chat assistants produce locally plausible, globally capacity-blind schedules — fluent text, invalid physics</a:t>
+              <a:t> — chat assistants produce locally plausible, globally capacity-blind schedules — fluent text, infeasible plans</a:t>
             </a:r>
           </a:p>
         </p:txBody>
@@ -4823,12 +4823,12 @@
           <a:p>
             <a:pPr algn="ctr"/>
             <a:r>
-              <a:rPr sz="4800" b="1">
+              <a:rPr sz="3000" b="1">
                 <a:solidFill>
                   <a:srgbClr val="AEE637"/>
                 </a:solidFill>
               </a:rPr>
-              <a:t>0.667</a:t>
+              <a:t>Baseline B</a:t>
             </a:r>
           </a:p>
           <a:p>
@@ -4838,7 +4838,7 @@
                   <a:srgbClr val="FFFFFF"/>
                 </a:solidFill>
               </a:rPr>
-              <a:t>violation-or-failure rate when the LLM schedules directly</a:t>
+              <a:t>LLM-only scheduling, measured on the demo machine</a:t>
             </a:r>
           </a:p>
           <a:p>
@@ -5814,7 +5814,7 @@
                   <a:srgbClr val="23322E"/>
                 </a:solidFill>
               </a:rPr>
-              <a:t>Guardrails, not hope</a:t>
+              <a:t>Guardrails by design</a:t>
             </a:r>
             <a:r>
               <a:rPr sz="1350">
@@ -6443,7 +6443,7 @@
                             <a:srgbClr val="23322E"/>
                           </a:solidFill>
                         </a:rPr>
-                        <a:t>LLM-only baseline fails 0.667 of runs; critic: 0</a:t>
+                        <a:t>LLM-only baseline measured on the demo machine; critic: 0 violations</a:t>
                       </a:r>
                     </a:p>
                   </a:txBody>
@@ -6495,7 +6495,7 @@
                 </a:solidFill>
                 <a:latin typeface="Calibri"/>
               </a:rPr>
-              <a:t>Excluded with argument: fine-tuning (LoRA on intent extraction is the named next step once prompting is the measured bottleneck), diffusion and multimodal (no image/audio modality in the problem — including them would be technique tourism).</a:t>
+              <a:t>Excluded with an explicit argument: fine-tuning (a LoRA pass on intent extraction is the named next step once prompting is the measured bottleneck); diffusion and multimodal models (no image or audio modality in the problem — they would add scope without a justified role).</a:t>
             </a:r>
           </a:p>
         </p:txBody>
@@ -7582,7 +7582,7 @@
                   <a:srgbClr val="0B1714"/>
                 </a:solidFill>
               </a:rPr>
-              <a:t>Break it on purpose — </a:t>
+              <a:t>Demonstrate rejection — </a:t>
             </a:r>
             <a:r>
               <a:rPr sz="1250">
@@ -7590,7 +7590,7 @@
                   <a:srgbClr val="6C7C76"/>
                 </a:solidFill>
               </a:rPr>
-              <a:t>impossible mission → the critic rejects; no invalid plan is ever shown</a:t>
+              <a:t>infeasible mission → the critic rejects it; no invalid plan is ever shown</a:t>
             </a:r>
           </a:p>
         </p:txBody>
@@ -8041,7 +8041,7 @@
                             <a:srgbClr val="23322E"/>
                           </a:solidFill>
                         </a:rPr>
-                        <a:t>0.65</a:t>
+                        <a:t>0.95</a:t>
                       </a:r>
                     </a:p>
                   </a:txBody>
@@ -8062,7 +8062,7 @@
                             <a:srgbClr val="23322E"/>
                           </a:solidFill>
                         </a:rPr>
-                        <a:t>0.9</a:t>
+                        <a:t>0.988</a:t>
                       </a:r>
                     </a:p>
                   </a:txBody>
@@ -8083,7 +8083,7 @@
                             <a:srgbClr val="23322E"/>
                           </a:solidFill>
                         </a:rPr>
-                        <a:t>0.762</a:t>
+                        <a:t>0.967</a:t>
                       </a:r>
                     </a:p>
                   </a:txBody>
@@ -8127,7 +8127,7 @@
                             <a:srgbClr val="23322E"/>
                           </a:solidFill>
                         </a:rPr>
-                        <a:t>0.875</a:t>
+                        <a:t>0.95</a:t>
                       </a:r>
                     </a:p>
                   </a:txBody>
@@ -8169,7 +8169,7 @@
                             <a:srgbClr val="23322E"/>
                           </a:solidFill>
                         </a:rPr>
-                        <a:t>0.938</a:t>
+                        <a:t>0.971</a:t>
                       </a:r>
                     </a:p>
                   </a:txBody>
@@ -8327,7 +8327,7 @@
                             <a:srgbClr val="23322E"/>
                           </a:solidFill>
                         </a:rPr>
-                        <a:t>0.667</a:t>
+                        <a:t>pending demo-machine run</a:t>
                       </a:r>
                     </a:p>
                   </a:txBody>
@@ -8511,7 +8511,7 @@
                 </a:solidFill>
                 <a:latin typeface="Consolas"/>
               </a:rPr>
-              <a:t>measured with mock-planner-1 · ollama embeddings · 51 chunks · 2026-08-24T12:07:24+00:00</a:t>
+              <a:t>measured with deterministic fallback · tfidf embeddings · 51 chunks · 2026-08-24T12:18:23+00:00</a:t>
             </a:r>
           </a:p>
         </p:txBody>
@@ -8758,7 +8758,7 @@
                   <a:srgbClr val="FFFFFF"/>
                 </a:solidFill>
               </a:rPr>
-              <a:t>▸ A real agent over real MCP tools, guardrails measured under rogue tests</a:t>
+              <a:t>▸ A real agent over real MCP tools; guardrails verified by adversarial tests</a:t>
             </a:r>
           </a:p>
           <a:p>

</xml_diff>